<commit_message>
Update presentation theme to light blue colour palette
Replaced forest green theme with a light blue scheme:
- Deep navy blue (#1B3F6B) for headers and dark backgrounds
- Sky blue (#5B9BD5) for accents and section bars
- Light blue (#E0F0FF) for slide backgrounds
- Pale blue (#C5DCF0) for alternating rows and cards
- Medium blue (#2E6DA4) for mid-tone elements

https://claude.ai/code/session_01F2ubz5sDJSzcvhb8wcjLuR
</commit_message>
<xml_diff>
--- a/marketing/TOCS-OC-Order-Portal-Marketing-Plan.pptx
+++ b/marketing/TOCS-OC-Order-Portal-Marketing-Plan.pptx
@@ -3094,7 +3094,7 @@
     <p:bg>
       <p:bgPr>
         <a:solidFill>
-          <a:srgbClr val="2D5016"/>
+          <a:srgbClr val="1B3F6B"/>
         </a:solidFill>
         <a:effectLst/>
       </p:bgPr>
@@ -3121,7 +3121,7 @@
             <a:avLst/>
           </a:prstGeom>
           <a:solidFill>
-            <a:srgbClr val="8FAF7E"/>
+            <a:srgbClr val="5B9BD5"/>
           </a:solidFill>
           <a:ln>
             <a:noFill/>
@@ -3164,7 +3164,7 @@
             <a:avLst/>
           </a:prstGeom>
           <a:solidFill>
-            <a:srgbClr val="8FAF7E"/>
+            <a:srgbClr val="5B9BD5"/>
           </a:solidFill>
           <a:ln>
             <a:noFill/>
@@ -3207,7 +3207,7 @@
             <a:avLst/>
           </a:prstGeom>
           <a:solidFill>
-            <a:srgbClr val="8FAF7E"/>
+            <a:srgbClr val="5B9BD5"/>
           </a:solidFill>
           <a:ln>
             <a:noFill/>
@@ -3261,7 +3261,7 @@
             <a:r>
               <a:rPr sz="2000" b="1" i="0">
                 <a:solidFill>
-                  <a:srgbClr val="2D5016"/>
+                  <a:srgbClr val="1B3F6B"/>
                 </a:solidFill>
                 <a:latin typeface="Calibri"/>
               </a:rPr>
@@ -3296,7 +3296,7 @@
             <a:r>
               <a:rPr sz="5200" b="1" i="0">
                 <a:solidFill>
-                  <a:srgbClr val="FFFFFF"/>
+                  <a:srgbClr val="E0F0FF"/>
                 </a:solidFill>
                 <a:latin typeface="Calibri"/>
               </a:rPr>
@@ -3331,7 +3331,7 @@
             <a:r>
               <a:rPr sz="2600" b="0" i="1">
                 <a:solidFill>
-                  <a:srgbClr val="F5F0E8"/>
+                  <a:srgbClr val="EBF5FB"/>
                 </a:solidFill>
                 <a:latin typeface="Calibri"/>
               </a:rPr>
@@ -3366,7 +3366,7 @@
             <a:r>
               <a:rPr sz="1600" b="0" i="0">
                 <a:solidFill>
-                  <a:srgbClr val="D6E8C8"/>
+                  <a:srgbClr val="C5DCF0"/>
                 </a:solidFill>
                 <a:latin typeface="Calibri"/>
               </a:rPr>
@@ -3401,7 +3401,7 @@
             <a:r>
               <a:rPr sz="1600" b="0" i="0">
                 <a:solidFill>
-                  <a:srgbClr val="D6E8C8"/>
+                  <a:srgbClr val="C5DCF0"/>
                 </a:solidFill>
                 <a:latin typeface="Calibri"/>
               </a:rPr>
@@ -3425,7 +3425,7 @@
             <a:avLst/>
           </a:prstGeom>
           <a:solidFill>
-            <a:srgbClr val="4A7A28"/>
+            <a:srgbClr val="2E6DA4"/>
           </a:solidFill>
           <a:ln>
             <a:noFill/>
@@ -3479,7 +3479,7 @@
             <a:r>
               <a:rPr sz="1200" b="0" i="0">
                 <a:solidFill>
-                  <a:srgbClr val="F5F0E8"/>
+                  <a:srgbClr val="EBF5FB"/>
                 </a:solidFill>
                 <a:latin typeface="Calibri"/>
               </a:rPr>
@@ -3502,7 +3502,7 @@
     <p:bg>
       <p:bgPr>
         <a:solidFill>
-          <a:srgbClr val="FFFFFF"/>
+          <a:srgbClr val="E0F0FF"/>
         </a:solidFill>
         <a:effectLst/>
       </p:bgPr>
@@ -3529,7 +3529,7 @@
             <a:avLst/>
           </a:prstGeom>
           <a:solidFill>
-            <a:srgbClr val="2D5016"/>
+            <a:srgbClr val="1B3F6B"/>
           </a:solidFill>
           <a:ln>
             <a:noFill/>
@@ -3583,7 +3583,7 @@
             <a:r>
               <a:rPr sz="3200" b="1" i="0">
                 <a:solidFill>
-                  <a:srgbClr val="FFFFFF"/>
+                  <a:srgbClr val="E0F0FF"/>
                 </a:solidFill>
                 <a:latin typeface="Calibri"/>
               </a:rPr>
@@ -3624,7 +3624,7 @@
                       <a:r>
                         <a:rPr sz="1300" b="1">
                           <a:solidFill>
-                            <a:srgbClr val="FFFFFF"/>
+                            <a:srgbClr val="E0F0FF"/>
                           </a:solidFill>
                           <a:latin typeface="Calibri"/>
                         </a:rPr>
@@ -3647,7 +3647,7 @@
                       <a:r>
                         <a:rPr sz="1300" b="1">
                           <a:solidFill>
-                            <a:srgbClr val="FFFFFF"/>
+                            <a:srgbClr val="E0F0FF"/>
                           </a:solidFill>
                           <a:latin typeface="Calibri"/>
                         </a:rPr>
@@ -3672,7 +3672,7 @@
                       <a:r>
                         <a:rPr sz="1200" b="1">
                           <a:solidFill>
-                            <a:srgbClr val="2D5016"/>
+                            <a:srgbClr val="1B3F6B"/>
                           </a:solidFill>
                           <a:latin typeface="Calibri"/>
                         </a:rPr>
@@ -3695,7 +3695,7 @@
                       <a:r>
                         <a:rPr sz="1200" b="0">
                           <a:solidFill>
-                            <a:srgbClr val="2C2C2C"/>
+                            <a:srgbClr val="1A2A3A"/>
                           </a:solidFill>
                           <a:latin typeface="Calibri"/>
                         </a:rPr>
@@ -3720,7 +3720,7 @@
                       <a:r>
                         <a:rPr sz="1200" b="1">
                           <a:solidFill>
-                            <a:srgbClr val="2D5016"/>
+                            <a:srgbClr val="1B3F6B"/>
                           </a:solidFill>
                           <a:latin typeface="Calibri"/>
                         </a:rPr>
@@ -3743,7 +3743,7 @@
                       <a:r>
                         <a:rPr sz="1200" b="0">
                           <a:solidFill>
-                            <a:srgbClr val="2C2C2C"/>
+                            <a:srgbClr val="1A2A3A"/>
                           </a:solidFill>
                           <a:latin typeface="Calibri"/>
                         </a:rPr>
@@ -3768,7 +3768,7 @@
                       <a:r>
                         <a:rPr sz="1200" b="1">
                           <a:solidFill>
-                            <a:srgbClr val="2D5016"/>
+                            <a:srgbClr val="1B3F6B"/>
                           </a:solidFill>
                           <a:latin typeface="Calibri"/>
                         </a:rPr>
@@ -3791,7 +3791,7 @@
                       <a:r>
                         <a:rPr sz="1200" b="0">
                           <a:solidFill>
-                            <a:srgbClr val="2C2C2C"/>
+                            <a:srgbClr val="1A2A3A"/>
                           </a:solidFill>
                           <a:latin typeface="Calibri"/>
                         </a:rPr>
@@ -3816,7 +3816,7 @@
                       <a:r>
                         <a:rPr sz="1200" b="1">
                           <a:solidFill>
-                            <a:srgbClr val="2D5016"/>
+                            <a:srgbClr val="1B3F6B"/>
                           </a:solidFill>
                           <a:latin typeface="Calibri"/>
                         </a:rPr>
@@ -3839,7 +3839,7 @@
                       <a:r>
                         <a:rPr sz="1200" b="0">
                           <a:solidFill>
-                            <a:srgbClr val="2C2C2C"/>
+                            <a:srgbClr val="1A2A3A"/>
                           </a:solidFill>
                           <a:latin typeface="Calibri"/>
                         </a:rPr>
@@ -3864,7 +3864,7 @@
                       <a:r>
                         <a:rPr sz="1200" b="1">
                           <a:solidFill>
-                            <a:srgbClr val="2D5016"/>
+                            <a:srgbClr val="1B3F6B"/>
                           </a:solidFill>
                           <a:latin typeface="Calibri"/>
                         </a:rPr>
@@ -3887,7 +3887,7 @@
                       <a:r>
                         <a:rPr sz="1200" b="0">
                           <a:solidFill>
-                            <a:srgbClr val="2C2C2C"/>
+                            <a:srgbClr val="1A2A3A"/>
                           </a:solidFill>
                           <a:latin typeface="Calibri"/>
                         </a:rPr>
@@ -3912,7 +3912,7 @@
                       <a:r>
                         <a:rPr sz="1200" b="1">
                           <a:solidFill>
-                            <a:srgbClr val="2D5016"/>
+                            <a:srgbClr val="1B3F6B"/>
                           </a:solidFill>
                           <a:latin typeface="Calibri"/>
                         </a:rPr>
@@ -3935,7 +3935,7 @@
                       <a:r>
                         <a:rPr sz="1200" b="0">
                           <a:solidFill>
-                            <a:srgbClr val="2C2C2C"/>
+                            <a:srgbClr val="1A2A3A"/>
                           </a:solidFill>
                           <a:latin typeface="Calibri"/>
                         </a:rPr>
@@ -3960,7 +3960,7 @@
                       <a:r>
                         <a:rPr sz="1200" b="1">
                           <a:solidFill>
-                            <a:srgbClr val="2D5016"/>
+                            <a:srgbClr val="1B3F6B"/>
                           </a:solidFill>
                           <a:latin typeface="Calibri"/>
                         </a:rPr>
@@ -3983,7 +3983,7 @@
                       <a:r>
                         <a:rPr sz="1200" b="0">
                           <a:solidFill>
-                            <a:srgbClr val="2C2C2C"/>
+                            <a:srgbClr val="1A2A3A"/>
                           </a:solidFill>
                           <a:latin typeface="Calibri"/>
                         </a:rPr>
@@ -4008,7 +4008,7 @@
                       <a:r>
                         <a:rPr sz="1200" b="1">
                           <a:solidFill>
-                            <a:srgbClr val="2D5016"/>
+                            <a:srgbClr val="1B3F6B"/>
                           </a:solidFill>
                           <a:latin typeface="Calibri"/>
                         </a:rPr>
@@ -4031,7 +4031,7 @@
                       <a:r>
                         <a:rPr sz="1200" b="0">
                           <a:solidFill>
-                            <a:srgbClr val="2C2C2C"/>
+                            <a:srgbClr val="1A2A3A"/>
                           </a:solidFill>
                           <a:latin typeface="Calibri"/>
                         </a:rPr>
@@ -4065,7 +4065,7 @@
             <a:avLst/>
           </a:prstGeom>
           <a:solidFill>
-            <a:srgbClr val="8FAF7E"/>
+            <a:srgbClr val="5B9BD5"/>
           </a:solidFill>
           <a:ln>
             <a:noFill/>
@@ -4119,7 +4119,7 @@
             <a:r>
               <a:rPr sz="1000" b="0" i="0">
                 <a:solidFill>
-                  <a:srgbClr val="2C2C2C"/>
+                  <a:srgbClr val="1A2A3A"/>
                 </a:solidFill>
                 <a:latin typeface="Calibri"/>
               </a:rPr>
@@ -4142,7 +4142,7 @@
     <p:bg>
       <p:bgPr>
         <a:solidFill>
-          <a:srgbClr val="2D5016"/>
+          <a:srgbClr val="1B3F6B"/>
         </a:solidFill>
         <a:effectLst/>
       </p:bgPr>
@@ -4169,7 +4169,7 @@
             <a:avLst/>
           </a:prstGeom>
           <a:solidFill>
-            <a:srgbClr val="8FAF7E"/>
+            <a:srgbClr val="5B9BD5"/>
           </a:solidFill>
           <a:ln>
             <a:noFill/>
@@ -4212,7 +4212,7 @@
             <a:avLst/>
           </a:prstGeom>
           <a:solidFill>
-            <a:srgbClr val="8FAF7E"/>
+            <a:srgbClr val="5B9BD5"/>
           </a:solidFill>
           <a:ln>
             <a:noFill/>
@@ -4255,7 +4255,7 @@
             <a:avLst/>
           </a:prstGeom>
           <a:solidFill>
-            <a:srgbClr val="8FAF7E"/>
+            <a:srgbClr val="5B9BD5"/>
           </a:solidFill>
           <a:ln>
             <a:noFill/>
@@ -4309,7 +4309,7 @@
             <a:r>
               <a:rPr sz="2000" b="1" i="0">
                 <a:solidFill>
-                  <a:srgbClr val="2D5016"/>
+                  <a:srgbClr val="1B3F6B"/>
                 </a:solidFill>
                 <a:latin typeface="Calibri"/>
               </a:rPr>
@@ -4344,7 +4344,7 @@
             <a:r>
               <a:rPr sz="4600" b="1" i="0">
                 <a:solidFill>
-                  <a:srgbClr val="FFFFFF"/>
+                  <a:srgbClr val="E0F0FF"/>
                 </a:solidFill>
                 <a:latin typeface="Calibri"/>
               </a:rPr>
@@ -4379,7 +4379,7 @@
             <a:r>
               <a:rPr sz="2200" b="1" i="0">
                 <a:solidFill>
-                  <a:srgbClr val="F5F0E8"/>
+                  <a:srgbClr val="EBF5FB"/>
                 </a:solidFill>
                 <a:latin typeface="Calibri"/>
               </a:rPr>
@@ -4414,7 +4414,7 @@
             <a:r>
               <a:rPr sz="1500" b="0" i="1">
                 <a:solidFill>
-                  <a:srgbClr val="D6E8C8"/>
+                  <a:srgbClr val="C5DCF0"/>
                 </a:solidFill>
                 <a:latin typeface="Calibri"/>
               </a:rPr>
@@ -4438,7 +4438,7 @@
             <a:avLst/>
           </a:prstGeom>
           <a:solidFill>
-            <a:srgbClr val="4A7A28"/>
+            <a:srgbClr val="2E6DA4"/>
           </a:solidFill>
           <a:ln>
             <a:noFill/>
@@ -4492,7 +4492,7 @@
             <a:r>
               <a:rPr sz="1300" b="1" i="0">
                 <a:solidFill>
-                  <a:srgbClr val="F5F0E8"/>
+                  <a:srgbClr val="EBF5FB"/>
                 </a:solidFill>
                 <a:latin typeface="Calibri"/>
               </a:rPr>
@@ -4527,7 +4527,7 @@
             <a:r>
               <a:rPr sz="1400" b="1" i="0">
                 <a:solidFill>
-                  <a:srgbClr val="FFFFFF"/>
+                  <a:srgbClr val="E0F0FF"/>
                 </a:solidFill>
                 <a:latin typeface="Calibri"/>
               </a:rPr>
@@ -4562,7 +4562,7 @@
             <a:r>
               <a:rPr sz="1200" b="0" i="0">
                 <a:solidFill>
-                  <a:srgbClr val="D6E8C8"/>
+                  <a:srgbClr val="C5DCF0"/>
                 </a:solidFill>
                 <a:latin typeface="Calibri"/>
               </a:rPr>
@@ -4586,7 +4586,7 @@
             <a:avLst/>
           </a:prstGeom>
           <a:solidFill>
-            <a:srgbClr val="4A7A28"/>
+            <a:srgbClr val="2E6DA4"/>
           </a:solidFill>
           <a:ln>
             <a:noFill/>
@@ -4640,7 +4640,7 @@
             <a:r>
               <a:rPr sz="1100" b="0" i="0">
                 <a:solidFill>
-                  <a:srgbClr val="F5F0E8"/>
+                  <a:srgbClr val="EBF5FB"/>
                 </a:solidFill>
                 <a:latin typeface="Calibri"/>
               </a:rPr>
@@ -4663,7 +4663,7 @@
     <p:bg>
       <p:bgPr>
         <a:solidFill>
-          <a:srgbClr val="FFFFFF"/>
+          <a:srgbClr val="E0F0FF"/>
         </a:solidFill>
         <a:effectLst/>
       </p:bgPr>
@@ -4690,7 +4690,7 @@
             <a:avLst/>
           </a:prstGeom>
           <a:solidFill>
-            <a:srgbClr val="2D5016"/>
+            <a:srgbClr val="1B3F6B"/>
           </a:solidFill>
           <a:ln>
             <a:noFill/>
@@ -4744,7 +4744,7 @@
             <a:r>
               <a:rPr sz="3200" b="1" i="0">
                 <a:solidFill>
-                  <a:srgbClr val="FFFFFF"/>
+                  <a:srgbClr val="E0F0FF"/>
                 </a:solidFill>
                 <a:latin typeface="Calibri"/>
               </a:rPr>
@@ -4768,7 +4768,7 @@
             <a:avLst/>
           </a:prstGeom>
           <a:solidFill>
-            <a:srgbClr val="2D5016"/>
+            <a:srgbClr val="1B3F6B"/>
           </a:solidFill>
           <a:ln>
             <a:noFill/>
@@ -4822,7 +4822,7 @@
             <a:r>
               <a:rPr sz="1300" b="1" i="0">
                 <a:solidFill>
-                  <a:srgbClr val="FFFFFF"/>
+                  <a:srgbClr val="E0F0FF"/>
                 </a:solidFill>
                 <a:latin typeface="Calibri"/>
               </a:rPr>
@@ -4846,7 +4846,7 @@
             <a:avLst/>
           </a:prstGeom>
           <a:solidFill>
-            <a:srgbClr val="D6E8C8"/>
+            <a:srgbClr val="C5DCF0"/>
           </a:solidFill>
           <a:ln>
             <a:noFill/>
@@ -4900,7 +4900,7 @@
             <a:r>
               <a:rPr sz="1100" b="0" i="0">
                 <a:solidFill>
-                  <a:srgbClr val="2C2C2C"/>
+                  <a:srgbClr val="1A2A3A"/>
                 </a:solidFill>
                 <a:latin typeface="Calibri"/>
               </a:rPr>
@@ -4924,7 +4924,7 @@
             <a:avLst/>
           </a:prstGeom>
           <a:solidFill>
-            <a:srgbClr val="2D5016"/>
+            <a:srgbClr val="1B3F6B"/>
           </a:solidFill>
           <a:ln>
             <a:noFill/>
@@ -4978,7 +4978,7 @@
             <a:r>
               <a:rPr sz="1300" b="1" i="0">
                 <a:solidFill>
-                  <a:srgbClr val="FFFFFF"/>
+                  <a:srgbClr val="E0F0FF"/>
                 </a:solidFill>
                 <a:latin typeface="Calibri"/>
               </a:rPr>
@@ -5002,7 +5002,7 @@
             <a:avLst/>
           </a:prstGeom>
           <a:solidFill>
-            <a:srgbClr val="D6E8C8"/>
+            <a:srgbClr val="C5DCF0"/>
           </a:solidFill>
           <a:ln>
             <a:noFill/>
@@ -5056,7 +5056,7 @@
             <a:r>
               <a:rPr sz="1100" b="0" i="0">
                 <a:solidFill>
-                  <a:srgbClr val="2C2C2C"/>
+                  <a:srgbClr val="1A2A3A"/>
                 </a:solidFill>
                 <a:latin typeface="Calibri"/>
               </a:rPr>
@@ -5080,7 +5080,7 @@
             <a:avLst/>
           </a:prstGeom>
           <a:solidFill>
-            <a:srgbClr val="2D5016"/>
+            <a:srgbClr val="1B3F6B"/>
           </a:solidFill>
           <a:ln>
             <a:noFill/>
@@ -5134,7 +5134,7 @@
             <a:r>
               <a:rPr sz="1300" b="1" i="0">
                 <a:solidFill>
-                  <a:srgbClr val="FFFFFF"/>
+                  <a:srgbClr val="E0F0FF"/>
                 </a:solidFill>
                 <a:latin typeface="Calibri"/>
               </a:rPr>
@@ -5158,7 +5158,7 @@
             <a:avLst/>
           </a:prstGeom>
           <a:solidFill>
-            <a:srgbClr val="D6E8C8"/>
+            <a:srgbClr val="C5DCF0"/>
           </a:solidFill>
           <a:ln>
             <a:noFill/>
@@ -5212,7 +5212,7 @@
             <a:r>
               <a:rPr sz="1100" b="0" i="0">
                 <a:solidFill>
-                  <a:srgbClr val="2C2C2C"/>
+                  <a:srgbClr val="1A2A3A"/>
                 </a:solidFill>
                 <a:latin typeface="Calibri"/>
               </a:rPr>
@@ -5236,7 +5236,7 @@
             <a:avLst/>
           </a:prstGeom>
           <a:solidFill>
-            <a:srgbClr val="8FAF7E"/>
+            <a:srgbClr val="5B9BD5"/>
           </a:solidFill>
           <a:ln>
             <a:noFill/>
@@ -5290,7 +5290,7 @@
             <a:r>
               <a:rPr sz="1000" b="0" i="0">
                 <a:solidFill>
-                  <a:srgbClr val="2C2C2C"/>
+                  <a:srgbClr val="1A2A3A"/>
                 </a:solidFill>
                 <a:latin typeface="Calibri"/>
               </a:rPr>
@@ -5313,7 +5313,7 @@
     <p:bg>
       <p:bgPr>
         <a:solidFill>
-          <a:srgbClr val="FFFFFF"/>
+          <a:srgbClr val="E0F0FF"/>
         </a:solidFill>
         <a:effectLst/>
       </p:bgPr>
@@ -5340,7 +5340,7 @@
             <a:avLst/>
           </a:prstGeom>
           <a:solidFill>
-            <a:srgbClr val="2D5016"/>
+            <a:srgbClr val="1B3F6B"/>
           </a:solidFill>
           <a:ln>
             <a:noFill/>
@@ -5394,7 +5394,7 @@
             <a:r>
               <a:rPr sz="3200" b="1" i="0">
                 <a:solidFill>
-                  <a:srgbClr val="FFFFFF"/>
+                  <a:srgbClr val="E0F0FF"/>
                 </a:solidFill>
                 <a:latin typeface="Calibri"/>
               </a:rPr>
@@ -5429,7 +5429,7 @@
             <a:r>
               <a:rPr sz="1600" b="0" i="1">
                 <a:solidFill>
-                  <a:srgbClr val="4A7A28"/>
+                  <a:srgbClr val="2E6DA4"/>
                 </a:solidFill>
                 <a:latin typeface="Calibri"/>
               </a:rPr>
@@ -5453,7 +5453,7 @@
             <a:avLst/>
           </a:prstGeom>
           <a:solidFill>
-            <a:srgbClr val="2D5016"/>
+            <a:srgbClr val="1B3F6B"/>
           </a:solidFill>
           <a:ln>
             <a:noFill/>
@@ -5507,7 +5507,7 @@
             <a:r>
               <a:rPr sz="1300" b="1" i="0">
                 <a:solidFill>
-                  <a:srgbClr val="FFFFFF"/>
+                  <a:srgbClr val="E0F0FF"/>
                 </a:solidFill>
                 <a:latin typeface="Calibri"/>
               </a:rPr>
@@ -5531,7 +5531,7 @@
             <a:avLst/>
           </a:prstGeom>
           <a:solidFill>
-            <a:srgbClr val="F5F0E8"/>
+            <a:srgbClr val="EBF5FB"/>
           </a:solidFill>
           <a:ln>
             <a:noFill/>
@@ -5585,7 +5585,7 @@
             <a:r>
               <a:rPr sz="1100" b="0" i="0">
                 <a:solidFill>
-                  <a:srgbClr val="2C2C2C"/>
+                  <a:srgbClr val="1A2A3A"/>
                 </a:solidFill>
                 <a:latin typeface="Calibri"/>
               </a:rPr>
@@ -5609,7 +5609,7 @@
             <a:avLst/>
           </a:prstGeom>
           <a:solidFill>
-            <a:srgbClr val="2D5016"/>
+            <a:srgbClr val="1B3F6B"/>
           </a:solidFill>
           <a:ln>
             <a:noFill/>
@@ -5663,7 +5663,7 @@
             <a:r>
               <a:rPr sz="1300" b="1" i="0">
                 <a:solidFill>
-                  <a:srgbClr val="FFFFFF"/>
+                  <a:srgbClr val="E0F0FF"/>
                 </a:solidFill>
                 <a:latin typeface="Calibri"/>
               </a:rPr>
@@ -5687,7 +5687,7 @@
             <a:avLst/>
           </a:prstGeom>
           <a:solidFill>
-            <a:srgbClr val="F5F0E8"/>
+            <a:srgbClr val="EBF5FB"/>
           </a:solidFill>
           <a:ln>
             <a:noFill/>
@@ -5741,7 +5741,7 @@
             <a:r>
               <a:rPr sz="1100" b="0" i="0">
                 <a:solidFill>
-                  <a:srgbClr val="2C2C2C"/>
+                  <a:srgbClr val="1A2A3A"/>
                 </a:solidFill>
                 <a:latin typeface="Calibri"/>
               </a:rPr>
@@ -5765,7 +5765,7 @@
             <a:avLst/>
           </a:prstGeom>
           <a:solidFill>
-            <a:srgbClr val="2D5016"/>
+            <a:srgbClr val="1B3F6B"/>
           </a:solidFill>
           <a:ln>
             <a:noFill/>
@@ -5819,7 +5819,7 @@
             <a:r>
               <a:rPr sz="1300" b="1" i="0">
                 <a:solidFill>
-                  <a:srgbClr val="FFFFFF"/>
+                  <a:srgbClr val="E0F0FF"/>
                 </a:solidFill>
                 <a:latin typeface="Calibri"/>
               </a:rPr>
@@ -5843,7 +5843,7 @@
             <a:avLst/>
           </a:prstGeom>
           <a:solidFill>
-            <a:srgbClr val="F5F0E8"/>
+            <a:srgbClr val="EBF5FB"/>
           </a:solidFill>
           <a:ln>
             <a:noFill/>
@@ -5897,7 +5897,7 @@
             <a:r>
               <a:rPr sz="1100" b="0" i="0">
                 <a:solidFill>
-                  <a:srgbClr val="2C2C2C"/>
+                  <a:srgbClr val="1A2A3A"/>
                 </a:solidFill>
                 <a:latin typeface="Calibri"/>
               </a:rPr>
@@ -5921,7 +5921,7 @@
             <a:avLst/>
           </a:prstGeom>
           <a:solidFill>
-            <a:srgbClr val="2D5016"/>
+            <a:srgbClr val="1B3F6B"/>
           </a:solidFill>
           <a:ln>
             <a:noFill/>
@@ -5975,7 +5975,7 @@
             <a:r>
               <a:rPr sz="1300" b="1" i="0">
                 <a:solidFill>
-                  <a:srgbClr val="FFFFFF"/>
+                  <a:srgbClr val="E0F0FF"/>
                 </a:solidFill>
                 <a:latin typeface="Calibri"/>
               </a:rPr>
@@ -5999,7 +5999,7 @@
             <a:avLst/>
           </a:prstGeom>
           <a:solidFill>
-            <a:srgbClr val="F5F0E8"/>
+            <a:srgbClr val="EBF5FB"/>
           </a:solidFill>
           <a:ln>
             <a:noFill/>
@@ -6053,7 +6053,7 @@
             <a:r>
               <a:rPr sz="1100" b="0" i="0">
                 <a:solidFill>
-                  <a:srgbClr val="2C2C2C"/>
+                  <a:srgbClr val="1A2A3A"/>
                 </a:solidFill>
                 <a:latin typeface="Calibri"/>
               </a:rPr>
@@ -6077,7 +6077,7 @@
             <a:avLst/>
           </a:prstGeom>
           <a:solidFill>
-            <a:srgbClr val="8FAF7E"/>
+            <a:srgbClr val="5B9BD5"/>
           </a:solidFill>
           <a:ln>
             <a:noFill/>
@@ -6131,7 +6131,7 @@
             <a:r>
               <a:rPr sz="1000" b="0" i="0">
                 <a:solidFill>
-                  <a:srgbClr val="2C2C2C"/>
+                  <a:srgbClr val="1A2A3A"/>
                 </a:solidFill>
                 <a:latin typeface="Calibri"/>
               </a:rPr>
@@ -6154,7 +6154,7 @@
     <p:bg>
       <p:bgPr>
         <a:solidFill>
-          <a:srgbClr val="FFFFFF"/>
+          <a:srgbClr val="E0F0FF"/>
         </a:solidFill>
         <a:effectLst/>
       </p:bgPr>
@@ -6181,7 +6181,7 @@
             <a:avLst/>
           </a:prstGeom>
           <a:solidFill>
-            <a:srgbClr val="2D5016"/>
+            <a:srgbClr val="1B3F6B"/>
           </a:solidFill>
           <a:ln>
             <a:noFill/>
@@ -6235,7 +6235,7 @@
             <a:r>
               <a:rPr sz="3200" b="1" i="0">
                 <a:solidFill>
-                  <a:srgbClr val="FFFFFF"/>
+                  <a:srgbClr val="E0F0FF"/>
                 </a:solidFill>
                 <a:latin typeface="Calibri"/>
               </a:rPr>
@@ -6259,7 +6259,7 @@
             <a:avLst/>
           </a:prstGeom>
           <a:solidFill>
-            <a:srgbClr val="2D5016"/>
+            <a:srgbClr val="1B3F6B"/>
           </a:solidFill>
           <a:ln>
             <a:noFill/>
@@ -6313,7 +6313,7 @@
             <a:r>
               <a:rPr sz="1300" b="1" i="0">
                 <a:solidFill>
-                  <a:srgbClr val="FFFFFF"/>
+                  <a:srgbClr val="E0F0FF"/>
                 </a:solidFill>
                 <a:latin typeface="Calibri"/>
               </a:rPr>
@@ -6337,7 +6337,7 @@
             <a:avLst/>
           </a:prstGeom>
           <a:solidFill>
-            <a:srgbClr val="D6E8C8"/>
+            <a:srgbClr val="C5DCF0"/>
           </a:solidFill>
           <a:ln>
             <a:noFill/>
@@ -6391,7 +6391,7 @@
             <a:r>
               <a:rPr sz="1100" b="0" i="0">
                 <a:solidFill>
-                  <a:srgbClr val="2C2C2C"/>
+                  <a:srgbClr val="1A2A3A"/>
                 </a:solidFill>
                 <a:latin typeface="Calibri"/>
               </a:rPr>
@@ -6415,7 +6415,7 @@
             <a:avLst/>
           </a:prstGeom>
           <a:solidFill>
-            <a:srgbClr val="2D5016"/>
+            <a:srgbClr val="1B3F6B"/>
           </a:solidFill>
           <a:ln>
             <a:noFill/>
@@ -6469,7 +6469,7 @@
             <a:r>
               <a:rPr sz="1300" b="1" i="0">
                 <a:solidFill>
-                  <a:srgbClr val="FFFFFF"/>
+                  <a:srgbClr val="E0F0FF"/>
                 </a:solidFill>
                 <a:latin typeface="Calibri"/>
               </a:rPr>
@@ -6493,7 +6493,7 @@
             <a:avLst/>
           </a:prstGeom>
           <a:solidFill>
-            <a:srgbClr val="D6E8C8"/>
+            <a:srgbClr val="C5DCF0"/>
           </a:solidFill>
           <a:ln>
             <a:noFill/>
@@ -6547,7 +6547,7 @@
             <a:r>
               <a:rPr sz="1100" b="0" i="0">
                 <a:solidFill>
-                  <a:srgbClr val="2C2C2C"/>
+                  <a:srgbClr val="1A2A3A"/>
                 </a:solidFill>
                 <a:latin typeface="Calibri"/>
               </a:rPr>
@@ -6571,7 +6571,7 @@
             <a:avLst/>
           </a:prstGeom>
           <a:solidFill>
-            <a:srgbClr val="2D5016"/>
+            <a:srgbClr val="1B3F6B"/>
           </a:solidFill>
           <a:ln>
             <a:noFill/>
@@ -6625,7 +6625,7 @@
             <a:r>
               <a:rPr sz="1300" b="1" i="0">
                 <a:solidFill>
-                  <a:srgbClr val="FFFFFF"/>
+                  <a:srgbClr val="E0F0FF"/>
                 </a:solidFill>
                 <a:latin typeface="Calibri"/>
               </a:rPr>
@@ -6649,7 +6649,7 @@
             <a:avLst/>
           </a:prstGeom>
           <a:solidFill>
-            <a:srgbClr val="D6E8C8"/>
+            <a:srgbClr val="C5DCF0"/>
           </a:solidFill>
           <a:ln>
             <a:noFill/>
@@ -6703,7 +6703,7 @@
             <a:r>
               <a:rPr sz="1100" b="0" i="0">
                 <a:solidFill>
-                  <a:srgbClr val="2C2C2C"/>
+                  <a:srgbClr val="1A2A3A"/>
                 </a:solidFill>
                 <a:latin typeface="Calibri"/>
               </a:rPr>
@@ -6727,7 +6727,7 @@
             <a:avLst/>
           </a:prstGeom>
           <a:solidFill>
-            <a:srgbClr val="2D5016"/>
+            <a:srgbClr val="1B3F6B"/>
           </a:solidFill>
           <a:ln>
             <a:noFill/>
@@ -6781,7 +6781,7 @@
             <a:r>
               <a:rPr sz="1300" b="1" i="0">
                 <a:solidFill>
-                  <a:srgbClr val="FFFFFF"/>
+                  <a:srgbClr val="E0F0FF"/>
                 </a:solidFill>
                 <a:latin typeface="Calibri"/>
               </a:rPr>
@@ -6805,7 +6805,7 @@
             <a:avLst/>
           </a:prstGeom>
           <a:solidFill>
-            <a:srgbClr val="D6E8C8"/>
+            <a:srgbClr val="C5DCF0"/>
           </a:solidFill>
           <a:ln>
             <a:noFill/>
@@ -6859,7 +6859,7 @@
             <a:r>
               <a:rPr sz="1100" b="0" i="0">
                 <a:solidFill>
-                  <a:srgbClr val="2C2C2C"/>
+                  <a:srgbClr val="1A2A3A"/>
                 </a:solidFill>
                 <a:latin typeface="Calibri"/>
               </a:rPr>
@@ -6883,7 +6883,7 @@
             <a:avLst/>
           </a:prstGeom>
           <a:solidFill>
-            <a:srgbClr val="8FAF7E"/>
+            <a:srgbClr val="5B9BD5"/>
           </a:solidFill>
           <a:ln>
             <a:noFill/>
@@ -6937,7 +6937,7 @@
             <a:r>
               <a:rPr sz="1000" b="0" i="0">
                 <a:solidFill>
-                  <a:srgbClr val="2C2C2C"/>
+                  <a:srgbClr val="1A2A3A"/>
                 </a:solidFill>
                 <a:latin typeface="Calibri"/>
               </a:rPr>
@@ -6960,7 +6960,7 @@
     <p:bg>
       <p:bgPr>
         <a:solidFill>
-          <a:srgbClr val="FFFFFF"/>
+          <a:srgbClr val="E0F0FF"/>
         </a:solidFill>
         <a:effectLst/>
       </p:bgPr>
@@ -6987,7 +6987,7 @@
             <a:avLst/>
           </a:prstGeom>
           <a:solidFill>
-            <a:srgbClr val="2D5016"/>
+            <a:srgbClr val="1B3F6B"/>
           </a:solidFill>
           <a:ln>
             <a:noFill/>
@@ -7041,7 +7041,7 @@
             <a:r>
               <a:rPr sz="3200" b="1" i="0">
                 <a:solidFill>
-                  <a:srgbClr val="FFFFFF"/>
+                  <a:srgbClr val="E0F0FF"/>
                 </a:solidFill>
                 <a:latin typeface="Calibri"/>
               </a:rPr>
@@ -7083,7 +7083,7 @@
                       <a:r>
                         <a:rPr sz="1300" b="1">
                           <a:solidFill>
-                            <a:srgbClr val="FFFFFF"/>
+                            <a:srgbClr val="E0F0FF"/>
                           </a:solidFill>
                           <a:latin typeface="Calibri"/>
                         </a:rPr>
@@ -7106,7 +7106,7 @@
                       <a:r>
                         <a:rPr sz="1300" b="1">
                           <a:solidFill>
-                            <a:srgbClr val="FFFFFF"/>
+                            <a:srgbClr val="E0F0FF"/>
                           </a:solidFill>
                           <a:latin typeface="Calibri"/>
                         </a:rPr>
@@ -7129,7 +7129,7 @@
                       <a:r>
                         <a:rPr sz="1300" b="1">
                           <a:solidFill>
-                            <a:srgbClr val="FFFFFF"/>
+                            <a:srgbClr val="E0F0FF"/>
                           </a:solidFill>
                           <a:latin typeface="Calibri"/>
                         </a:rPr>
@@ -7154,7 +7154,7 @@
                       <a:r>
                         <a:rPr sz="1200" b="0">
                           <a:solidFill>
-                            <a:srgbClr val="2C2C2C"/>
+                            <a:srgbClr val="1A2A3A"/>
                           </a:solidFill>
                           <a:latin typeface="Calibri"/>
                         </a:rPr>
@@ -7177,7 +7177,7 @@
                       <a:r>
                         <a:rPr sz="1200" b="0">
                           <a:solidFill>
-                            <a:srgbClr val="2C2C2C"/>
+                            <a:srgbClr val="1A2A3A"/>
                           </a:solidFill>
                           <a:latin typeface="Calibri"/>
                         </a:rPr>
@@ -7200,7 +7200,7 @@
                       <a:r>
                         <a:rPr sz="1200" b="0">
                           <a:solidFill>
-                            <a:srgbClr val="2C2C2C"/>
+                            <a:srgbClr val="1A2A3A"/>
                           </a:solidFill>
                           <a:latin typeface="Calibri"/>
                         </a:rPr>
@@ -7225,7 +7225,7 @@
                       <a:r>
                         <a:rPr sz="1200" b="0">
                           <a:solidFill>
-                            <a:srgbClr val="2C2C2C"/>
+                            <a:srgbClr val="1A2A3A"/>
                           </a:solidFill>
                           <a:latin typeface="Calibri"/>
                         </a:rPr>
@@ -7248,7 +7248,7 @@
                       <a:r>
                         <a:rPr sz="1200" b="0">
                           <a:solidFill>
-                            <a:srgbClr val="2C2C2C"/>
+                            <a:srgbClr val="1A2A3A"/>
                           </a:solidFill>
                           <a:latin typeface="Calibri"/>
                         </a:rPr>
@@ -7271,7 +7271,7 @@
                       <a:r>
                         <a:rPr sz="1200" b="0">
                           <a:solidFill>
-                            <a:srgbClr val="2C2C2C"/>
+                            <a:srgbClr val="1A2A3A"/>
                           </a:solidFill>
                           <a:latin typeface="Calibri"/>
                         </a:rPr>
@@ -7296,7 +7296,7 @@
                       <a:r>
                         <a:rPr sz="1200" b="0">
                           <a:solidFill>
-                            <a:srgbClr val="2C2C2C"/>
+                            <a:srgbClr val="1A2A3A"/>
                           </a:solidFill>
                           <a:latin typeface="Calibri"/>
                         </a:rPr>
@@ -7319,7 +7319,7 @@
                       <a:r>
                         <a:rPr sz="1200" b="0">
                           <a:solidFill>
-                            <a:srgbClr val="2C2C2C"/>
+                            <a:srgbClr val="1A2A3A"/>
                           </a:solidFill>
                           <a:latin typeface="Calibri"/>
                         </a:rPr>
@@ -7342,7 +7342,7 @@
                       <a:r>
                         <a:rPr sz="1200" b="0">
                           <a:solidFill>
-                            <a:srgbClr val="2C2C2C"/>
+                            <a:srgbClr val="1A2A3A"/>
                           </a:solidFill>
                           <a:latin typeface="Calibri"/>
                         </a:rPr>
@@ -7367,7 +7367,7 @@
                       <a:r>
                         <a:rPr sz="1200" b="0">
                           <a:solidFill>
-                            <a:srgbClr val="2C2C2C"/>
+                            <a:srgbClr val="1A2A3A"/>
                           </a:solidFill>
                           <a:latin typeface="Calibri"/>
                         </a:rPr>
@@ -7390,7 +7390,7 @@
                       <a:r>
                         <a:rPr sz="1200" b="0">
                           <a:solidFill>
-                            <a:srgbClr val="2C2C2C"/>
+                            <a:srgbClr val="1A2A3A"/>
                           </a:solidFill>
                           <a:latin typeface="Calibri"/>
                         </a:rPr>
@@ -7413,7 +7413,7 @@
                       <a:r>
                         <a:rPr sz="1200" b="0">
                           <a:solidFill>
-                            <a:srgbClr val="2C2C2C"/>
+                            <a:srgbClr val="1A2A3A"/>
                           </a:solidFill>
                           <a:latin typeface="Calibri"/>
                         </a:rPr>
@@ -7438,7 +7438,7 @@
                       <a:r>
                         <a:rPr sz="1200" b="0">
                           <a:solidFill>
-                            <a:srgbClr val="2C2C2C"/>
+                            <a:srgbClr val="1A2A3A"/>
                           </a:solidFill>
                           <a:latin typeface="Calibri"/>
                         </a:rPr>
@@ -7461,7 +7461,7 @@
                       <a:r>
                         <a:rPr sz="1200" b="0">
                           <a:solidFill>
-                            <a:srgbClr val="2C2C2C"/>
+                            <a:srgbClr val="1A2A3A"/>
                           </a:solidFill>
                           <a:latin typeface="Calibri"/>
                         </a:rPr>
@@ -7484,7 +7484,7 @@
                       <a:r>
                         <a:rPr sz="1200" b="0">
                           <a:solidFill>
-                            <a:srgbClr val="2C2C2C"/>
+                            <a:srgbClr val="1A2A3A"/>
                           </a:solidFill>
                           <a:latin typeface="Calibri"/>
                         </a:rPr>
@@ -7509,7 +7509,7 @@
                       <a:r>
                         <a:rPr sz="1200" b="0">
                           <a:solidFill>
-                            <a:srgbClr val="2C2C2C"/>
+                            <a:srgbClr val="1A2A3A"/>
                           </a:solidFill>
                           <a:latin typeface="Calibri"/>
                         </a:rPr>
@@ -7532,7 +7532,7 @@
                       <a:r>
                         <a:rPr sz="1200" b="0">
                           <a:solidFill>
-                            <a:srgbClr val="2C2C2C"/>
+                            <a:srgbClr val="1A2A3A"/>
                           </a:solidFill>
                           <a:latin typeface="Calibri"/>
                         </a:rPr>
@@ -7555,7 +7555,7 @@
                       <a:r>
                         <a:rPr sz="1200" b="0">
                           <a:solidFill>
-                            <a:srgbClr val="2C2C2C"/>
+                            <a:srgbClr val="1A2A3A"/>
                           </a:solidFill>
                           <a:latin typeface="Calibri"/>
                         </a:rPr>
@@ -7589,7 +7589,7 @@
             <a:avLst/>
           </a:prstGeom>
           <a:solidFill>
-            <a:srgbClr val="8FAF7E"/>
+            <a:srgbClr val="5B9BD5"/>
           </a:solidFill>
           <a:ln>
             <a:noFill/>
@@ -7643,7 +7643,7 @@
             <a:r>
               <a:rPr sz="1000" b="0" i="0">
                 <a:solidFill>
-                  <a:srgbClr val="2C2C2C"/>
+                  <a:srgbClr val="1A2A3A"/>
                 </a:solidFill>
                 <a:latin typeface="Calibri"/>
               </a:rPr>
@@ -7666,7 +7666,7 @@
     <p:bg>
       <p:bgPr>
         <a:solidFill>
-          <a:srgbClr val="2D5016"/>
+          <a:srgbClr val="1B3F6B"/>
         </a:solidFill>
         <a:effectLst/>
       </p:bgPr>
@@ -7693,7 +7693,7 @@
             <a:avLst/>
           </a:prstGeom>
           <a:solidFill>
-            <a:srgbClr val="4A7A28"/>
+            <a:srgbClr val="2E6DA4"/>
           </a:solidFill>
           <a:ln>
             <a:noFill/>
@@ -7747,7 +7747,7 @@
             <a:r>
               <a:rPr sz="3200" b="1" i="0">
                 <a:solidFill>
-                  <a:srgbClr val="FFFFFF"/>
+                  <a:srgbClr val="E0F0FF"/>
                 </a:solidFill>
                 <a:latin typeface="Calibri"/>
               </a:rPr>
@@ -7771,7 +7771,7 @@
             <a:avLst/>
           </a:prstGeom>
           <a:solidFill>
-            <a:srgbClr val="4A7A28"/>
+            <a:srgbClr val="2E6DA4"/>
           </a:solidFill>
           <a:ln>
             <a:noFill/>
@@ -7825,7 +7825,7 @@
             <a:r>
               <a:rPr sz="3400" b="1" i="0">
                 <a:solidFill>
-                  <a:srgbClr val="F5F0E8"/>
+                  <a:srgbClr val="EBF5FB"/>
                 </a:solidFill>
                 <a:latin typeface="Calibri"/>
               </a:rPr>
@@ -7860,7 +7860,7 @@
             <a:r>
               <a:rPr sz="1400" b="0" i="0">
                 <a:solidFill>
-                  <a:srgbClr val="D6E8C8"/>
+                  <a:srgbClr val="C5DCF0"/>
                 </a:solidFill>
                 <a:latin typeface="Calibri"/>
               </a:rPr>
@@ -7884,7 +7884,7 @@
             <a:avLst/>
           </a:prstGeom>
           <a:solidFill>
-            <a:srgbClr val="4A7A28"/>
+            <a:srgbClr val="2E6DA4"/>
           </a:solidFill>
           <a:ln>
             <a:noFill/>
@@ -7938,7 +7938,7 @@
             <a:r>
               <a:rPr sz="3400" b="1" i="0">
                 <a:solidFill>
-                  <a:srgbClr val="F5F0E8"/>
+                  <a:srgbClr val="EBF5FB"/>
                 </a:solidFill>
                 <a:latin typeface="Calibri"/>
               </a:rPr>
@@ -7973,7 +7973,7 @@
             <a:r>
               <a:rPr sz="1400" b="0" i="0">
                 <a:solidFill>
-                  <a:srgbClr val="D6E8C8"/>
+                  <a:srgbClr val="C5DCF0"/>
                 </a:solidFill>
                 <a:latin typeface="Calibri"/>
               </a:rPr>
@@ -7997,7 +7997,7 @@
             <a:avLst/>
           </a:prstGeom>
           <a:solidFill>
-            <a:srgbClr val="4A7A28"/>
+            <a:srgbClr val="2E6DA4"/>
           </a:solidFill>
           <a:ln>
             <a:noFill/>
@@ -8051,7 +8051,7 @@
             <a:r>
               <a:rPr sz="3400" b="1" i="0">
                 <a:solidFill>
-                  <a:srgbClr val="F5F0E8"/>
+                  <a:srgbClr val="EBF5FB"/>
                 </a:solidFill>
                 <a:latin typeface="Calibri"/>
               </a:rPr>
@@ -8086,7 +8086,7 @@
             <a:r>
               <a:rPr sz="1400" b="0" i="0">
                 <a:solidFill>
-                  <a:srgbClr val="D6E8C8"/>
+                  <a:srgbClr val="C5DCF0"/>
                 </a:solidFill>
                 <a:latin typeface="Calibri"/>
               </a:rPr>
@@ -8110,7 +8110,7 @@
             <a:avLst/>
           </a:prstGeom>
           <a:solidFill>
-            <a:srgbClr val="4A7A28"/>
+            <a:srgbClr val="2E6DA4"/>
           </a:solidFill>
           <a:ln>
             <a:noFill/>
@@ -8164,7 +8164,7 @@
             <a:r>
               <a:rPr sz="3400" b="1" i="0">
                 <a:solidFill>
-                  <a:srgbClr val="F5F0E8"/>
+                  <a:srgbClr val="EBF5FB"/>
                 </a:solidFill>
                 <a:latin typeface="Calibri"/>
               </a:rPr>
@@ -8199,7 +8199,7 @@
             <a:r>
               <a:rPr sz="1400" b="0" i="0">
                 <a:solidFill>
-                  <a:srgbClr val="D6E8C8"/>
+                  <a:srgbClr val="C5DCF0"/>
                 </a:solidFill>
                 <a:latin typeface="Calibri"/>
               </a:rPr>
@@ -8223,7 +8223,7 @@
             <a:avLst/>
           </a:prstGeom>
           <a:solidFill>
-            <a:srgbClr val="8FAF7E"/>
+            <a:srgbClr val="5B9BD5"/>
           </a:solidFill>
           <a:ln>
             <a:noFill/>
@@ -8277,7 +8277,7 @@
             <a:r>
               <a:rPr sz="1000" b="0" i="0">
                 <a:solidFill>
-                  <a:srgbClr val="F5F0E8"/>
+                  <a:srgbClr val="EBF5FB"/>
                 </a:solidFill>
                 <a:latin typeface="Calibri"/>
               </a:rPr>
@@ -8300,7 +8300,7 @@
     <p:bg>
       <p:bgPr>
         <a:solidFill>
-          <a:srgbClr val="FFFFFF"/>
+          <a:srgbClr val="E0F0FF"/>
         </a:solidFill>
         <a:effectLst/>
       </p:bgPr>
@@ -8327,7 +8327,7 @@
             <a:avLst/>
           </a:prstGeom>
           <a:solidFill>
-            <a:srgbClr val="2D5016"/>
+            <a:srgbClr val="1B3F6B"/>
           </a:solidFill>
           <a:ln>
             <a:noFill/>
@@ -8381,7 +8381,7 @@
             <a:r>
               <a:rPr sz="3200" b="1" i="0">
                 <a:solidFill>
-                  <a:srgbClr val="FFFFFF"/>
+                  <a:srgbClr val="E0F0FF"/>
                 </a:solidFill>
                 <a:latin typeface="Calibri"/>
               </a:rPr>
@@ -8416,7 +8416,7 @@
             <a:r>
               <a:rPr sz="1500" b="0" i="1">
                 <a:solidFill>
-                  <a:srgbClr val="4A7A28"/>
+                  <a:srgbClr val="2E6DA4"/>
                 </a:solidFill>
                 <a:latin typeface="Calibri"/>
               </a:rPr>
@@ -8440,7 +8440,7 @@
             <a:avLst/>
           </a:prstGeom>
           <a:solidFill>
-            <a:srgbClr val="2D5016"/>
+            <a:srgbClr val="1B3F6B"/>
           </a:solidFill>
           <a:ln>
             <a:noFill/>
@@ -8494,7 +8494,7 @@
             <a:r>
               <a:rPr sz="1300" b="1" i="0">
                 <a:solidFill>
-                  <a:srgbClr val="FFFFFF"/>
+                  <a:srgbClr val="E0F0FF"/>
                 </a:solidFill>
                 <a:latin typeface="Calibri"/>
               </a:rPr>
@@ -8529,7 +8529,7 @@
             <a:r>
               <a:rPr sz="1200" b="0" i="1">
                 <a:solidFill>
-                  <a:srgbClr val="FFFFFF"/>
+                  <a:srgbClr val="E0F0FF"/>
                 </a:solidFill>
                 <a:latin typeface="Calibri"/>
               </a:rPr>
@@ -8553,7 +8553,7 @@
             <a:avLst/>
           </a:prstGeom>
           <a:solidFill>
-            <a:srgbClr val="F5F0E8"/>
+            <a:srgbClr val="EBF5FB"/>
           </a:solidFill>
           <a:ln>
             <a:noFill/>
@@ -8607,7 +8607,7 @@
             <a:r>
               <a:rPr sz="1300" b="1" i="0">
                 <a:solidFill>
-                  <a:srgbClr val="FFFFFF"/>
+                  <a:srgbClr val="E0F0FF"/>
                 </a:solidFill>
                 <a:latin typeface="Calibri"/>
               </a:rPr>
@@ -8642,7 +8642,7 @@
             <a:r>
               <a:rPr sz="1100" b="0" i="0">
                 <a:solidFill>
-                  <a:srgbClr val="FFFFFF"/>
+                  <a:srgbClr val="E0F0FF"/>
                 </a:solidFill>
                 <a:latin typeface="Calibri"/>
               </a:rPr>
@@ -8666,7 +8666,7 @@
             <a:avLst/>
           </a:prstGeom>
           <a:solidFill>
-            <a:srgbClr val="4A7A28"/>
+            <a:srgbClr val="2E6DA4"/>
           </a:solidFill>
           <a:ln>
             <a:noFill/>
@@ -8720,7 +8720,7 @@
             <a:r>
               <a:rPr sz="1300" b="1" i="0">
                 <a:solidFill>
-                  <a:srgbClr val="FFFFFF"/>
+                  <a:srgbClr val="E0F0FF"/>
                 </a:solidFill>
                 <a:latin typeface="Calibri"/>
               </a:rPr>
@@ -8755,7 +8755,7 @@
             <a:r>
               <a:rPr sz="1200" b="0" i="1">
                 <a:solidFill>
-                  <a:srgbClr val="FFFFFF"/>
+                  <a:srgbClr val="E0F0FF"/>
                 </a:solidFill>
                 <a:latin typeface="Calibri"/>
               </a:rPr>
@@ -8779,7 +8779,7 @@
             <a:avLst/>
           </a:prstGeom>
           <a:solidFill>
-            <a:srgbClr val="F5F0E8"/>
+            <a:srgbClr val="EBF5FB"/>
           </a:solidFill>
           <a:ln>
             <a:noFill/>
@@ -8833,7 +8833,7 @@
             <a:r>
               <a:rPr sz="1300" b="1" i="0">
                 <a:solidFill>
-                  <a:srgbClr val="FFFFFF"/>
+                  <a:srgbClr val="E0F0FF"/>
                 </a:solidFill>
                 <a:latin typeface="Calibri"/>
               </a:rPr>
@@ -8868,7 +8868,7 @@
             <a:r>
               <a:rPr sz="1100" b="0" i="0">
                 <a:solidFill>
-                  <a:srgbClr val="FFFFFF"/>
+                  <a:srgbClr val="E0F0FF"/>
                 </a:solidFill>
                 <a:latin typeface="Calibri"/>
               </a:rPr>
@@ -8892,7 +8892,7 @@
             <a:avLst/>
           </a:prstGeom>
           <a:solidFill>
-            <a:srgbClr val="8FAF7E"/>
+            <a:srgbClr val="5B9BD5"/>
           </a:solidFill>
           <a:ln>
             <a:noFill/>
@@ -8946,7 +8946,7 @@
             <a:r>
               <a:rPr sz="1300" b="1" i="0">
                 <a:solidFill>
-                  <a:srgbClr val="2C2C2C"/>
+                  <a:srgbClr val="1A2A3A"/>
                 </a:solidFill>
                 <a:latin typeface="Calibri"/>
               </a:rPr>
@@ -8981,7 +8981,7 @@
             <a:r>
               <a:rPr sz="1200" b="0" i="1">
                 <a:solidFill>
-                  <a:srgbClr val="2C2C2C"/>
+                  <a:srgbClr val="1A2A3A"/>
                 </a:solidFill>
                 <a:latin typeface="Calibri"/>
               </a:rPr>
@@ -9005,7 +9005,7 @@
             <a:avLst/>
           </a:prstGeom>
           <a:solidFill>
-            <a:srgbClr val="2D5016"/>
+            <a:srgbClr val="1B3F6B"/>
           </a:solidFill>
           <a:ln>
             <a:noFill/>
@@ -9059,7 +9059,7 @@
             <a:r>
               <a:rPr sz="1300" b="1" i="0">
                 <a:solidFill>
-                  <a:srgbClr val="2C2C2C"/>
+                  <a:srgbClr val="1A2A3A"/>
                 </a:solidFill>
                 <a:latin typeface="Calibri"/>
               </a:rPr>
@@ -9094,7 +9094,7 @@
             <a:r>
               <a:rPr sz="1100" b="0" i="0">
                 <a:solidFill>
-                  <a:srgbClr val="2C2C2C"/>
+                  <a:srgbClr val="1A2A3A"/>
                 </a:solidFill>
                 <a:latin typeface="Calibri"/>
               </a:rPr>
@@ -9118,7 +9118,7 @@
             <a:avLst/>
           </a:prstGeom>
           <a:solidFill>
-            <a:srgbClr val="D6E8C8"/>
+            <a:srgbClr val="C5DCF0"/>
           </a:solidFill>
           <a:ln>
             <a:noFill/>
@@ -9172,7 +9172,7 @@
             <a:r>
               <a:rPr sz="1300" b="1" i="0">
                 <a:solidFill>
-                  <a:srgbClr val="2C2C2C"/>
+                  <a:srgbClr val="1A2A3A"/>
                 </a:solidFill>
                 <a:latin typeface="Calibri"/>
               </a:rPr>
@@ -9207,7 +9207,7 @@
             <a:r>
               <a:rPr sz="1200" b="0" i="1">
                 <a:solidFill>
-                  <a:srgbClr val="2C2C2C"/>
+                  <a:srgbClr val="1A2A3A"/>
                 </a:solidFill>
                 <a:latin typeface="Calibri"/>
               </a:rPr>
@@ -9231,7 +9231,7 @@
             <a:avLst/>
           </a:prstGeom>
           <a:solidFill>
-            <a:srgbClr val="2D5016"/>
+            <a:srgbClr val="1B3F6B"/>
           </a:solidFill>
           <a:ln>
             <a:noFill/>
@@ -9285,7 +9285,7 @@
             <a:r>
               <a:rPr sz="1300" b="1" i="0">
                 <a:solidFill>
-                  <a:srgbClr val="2C2C2C"/>
+                  <a:srgbClr val="1A2A3A"/>
                 </a:solidFill>
                 <a:latin typeface="Calibri"/>
               </a:rPr>
@@ -9320,7 +9320,7 @@
             <a:r>
               <a:rPr sz="1100" b="0" i="0">
                 <a:solidFill>
-                  <a:srgbClr val="2C2C2C"/>
+                  <a:srgbClr val="1A2A3A"/>
                 </a:solidFill>
                 <a:latin typeface="Calibri"/>
               </a:rPr>
@@ -9344,7 +9344,7 @@
             <a:avLst/>
           </a:prstGeom>
           <a:solidFill>
-            <a:srgbClr val="8FAF7E"/>
+            <a:srgbClr val="5B9BD5"/>
           </a:solidFill>
           <a:ln>
             <a:noFill/>
@@ -9398,7 +9398,7 @@
             <a:r>
               <a:rPr sz="1000" b="0" i="0">
                 <a:solidFill>
-                  <a:srgbClr val="2C2C2C"/>
+                  <a:srgbClr val="1A2A3A"/>
                 </a:solidFill>
                 <a:latin typeface="Calibri"/>
               </a:rPr>
@@ -9421,7 +9421,7 @@
     <p:bg>
       <p:bgPr>
         <a:solidFill>
-          <a:srgbClr val="FFFFFF"/>
+          <a:srgbClr val="E0F0FF"/>
         </a:solidFill>
         <a:effectLst/>
       </p:bgPr>
@@ -9448,7 +9448,7 @@
             <a:avLst/>
           </a:prstGeom>
           <a:solidFill>
-            <a:srgbClr val="2D5016"/>
+            <a:srgbClr val="1B3F6B"/>
           </a:solidFill>
           <a:ln>
             <a:noFill/>
@@ -9502,7 +9502,7 @@
             <a:r>
               <a:rPr sz="3200" b="1" i="0">
                 <a:solidFill>
-                  <a:srgbClr val="FFFFFF"/>
+                  <a:srgbClr val="E0F0FF"/>
                 </a:solidFill>
                 <a:latin typeface="Calibri"/>
               </a:rPr>
@@ -9526,7 +9526,7 @@
             <a:avLst/>
           </a:prstGeom>
           <a:solidFill>
-            <a:srgbClr val="2D5016"/>
+            <a:srgbClr val="1B3F6B"/>
           </a:solidFill>
           <a:ln>
             <a:noFill/>
@@ -9580,7 +9580,7 @@
             <a:r>
               <a:rPr sz="1300" b="1" i="0">
                 <a:solidFill>
-                  <a:srgbClr val="FFFFFF"/>
+                  <a:srgbClr val="E0F0FF"/>
                 </a:solidFill>
                 <a:latin typeface="Calibri"/>
               </a:rPr>
@@ -9604,7 +9604,7 @@
             <a:avLst/>
           </a:prstGeom>
           <a:solidFill>
-            <a:srgbClr val="F5F0E8"/>
+            <a:srgbClr val="EBF5FB"/>
           </a:solidFill>
           <a:ln>
             <a:noFill/>
@@ -9658,7 +9658,7 @@
             <a:r>
               <a:rPr sz="1100" b="0" i="0">
                 <a:solidFill>
-                  <a:srgbClr val="2C2C2C"/>
+                  <a:srgbClr val="1A2A3A"/>
                 </a:solidFill>
                 <a:latin typeface="Calibri"/>
               </a:rPr>
@@ -9686,7 +9686,7 @@
             <a:avLst/>
           </a:prstGeom>
           <a:solidFill>
-            <a:srgbClr val="2D5016"/>
+            <a:srgbClr val="1B3F6B"/>
           </a:solidFill>
           <a:ln>
             <a:noFill/>
@@ -9740,7 +9740,7 @@
             <a:r>
               <a:rPr sz="1300" b="1" i="0">
                 <a:solidFill>
-                  <a:srgbClr val="FFFFFF"/>
+                  <a:srgbClr val="E0F0FF"/>
                 </a:solidFill>
                 <a:latin typeface="Calibri"/>
               </a:rPr>
@@ -9764,7 +9764,7 @@
             <a:avLst/>
           </a:prstGeom>
           <a:solidFill>
-            <a:srgbClr val="F5F0E8"/>
+            <a:srgbClr val="EBF5FB"/>
           </a:solidFill>
           <a:ln>
             <a:noFill/>
@@ -9818,7 +9818,7 @@
             <a:r>
               <a:rPr sz="1100" b="0" i="0">
                 <a:solidFill>
-                  <a:srgbClr val="2C2C2C"/>
+                  <a:srgbClr val="1A2A3A"/>
                 </a:solidFill>
                 <a:latin typeface="Calibri"/>
               </a:rPr>
@@ -9844,7 +9844,7 @@
             <a:avLst/>
           </a:prstGeom>
           <a:solidFill>
-            <a:srgbClr val="2D5016"/>
+            <a:srgbClr val="1B3F6B"/>
           </a:solidFill>
           <a:ln>
             <a:noFill/>
@@ -9898,7 +9898,7 @@
             <a:r>
               <a:rPr sz="1300" b="1" i="0">
                 <a:solidFill>
-                  <a:srgbClr val="FFFFFF"/>
+                  <a:srgbClr val="E0F0FF"/>
                 </a:solidFill>
                 <a:latin typeface="Calibri"/>
               </a:rPr>
@@ -9922,7 +9922,7 @@
             <a:avLst/>
           </a:prstGeom>
           <a:solidFill>
-            <a:srgbClr val="F5F0E8"/>
+            <a:srgbClr val="EBF5FB"/>
           </a:solidFill>
           <a:ln>
             <a:noFill/>
@@ -9976,7 +9976,7 @@
             <a:r>
               <a:rPr sz="1100" b="0" i="0">
                 <a:solidFill>
-                  <a:srgbClr val="2C2C2C"/>
+                  <a:srgbClr val="1A2A3A"/>
                 </a:solidFill>
                 <a:latin typeface="Calibri"/>
               </a:rPr>
@@ -10002,7 +10002,7 @@
             <a:avLst/>
           </a:prstGeom>
           <a:solidFill>
-            <a:srgbClr val="2D5016"/>
+            <a:srgbClr val="1B3F6B"/>
           </a:solidFill>
           <a:ln>
             <a:noFill/>
@@ -10056,7 +10056,7 @@
             <a:r>
               <a:rPr sz="1300" b="1" i="0">
                 <a:solidFill>
-                  <a:srgbClr val="FFFFFF"/>
+                  <a:srgbClr val="E0F0FF"/>
                 </a:solidFill>
                 <a:latin typeface="Calibri"/>
               </a:rPr>
@@ -10080,7 +10080,7 @@
             <a:avLst/>
           </a:prstGeom>
           <a:solidFill>
-            <a:srgbClr val="F5F0E8"/>
+            <a:srgbClr val="EBF5FB"/>
           </a:solidFill>
           <a:ln>
             <a:noFill/>
@@ -10134,7 +10134,7 @@
             <a:r>
               <a:rPr sz="1100" b="0" i="0">
                 <a:solidFill>
-                  <a:srgbClr val="2C2C2C"/>
+                  <a:srgbClr val="1A2A3A"/>
                 </a:solidFill>
                 <a:latin typeface="Calibri"/>
               </a:rPr>
@@ -10161,7 +10161,7 @@
             <a:avLst/>
           </a:prstGeom>
           <a:solidFill>
-            <a:srgbClr val="8FAF7E"/>
+            <a:srgbClr val="5B9BD5"/>
           </a:solidFill>
           <a:ln>
             <a:noFill/>
@@ -10215,7 +10215,7 @@
             <a:r>
               <a:rPr sz="1000" b="0" i="0">
                 <a:solidFill>
-                  <a:srgbClr val="2C2C2C"/>
+                  <a:srgbClr val="1A2A3A"/>
                 </a:solidFill>
                 <a:latin typeface="Calibri"/>
               </a:rPr>
@@ -10238,7 +10238,7 @@
     <p:bg>
       <p:bgPr>
         <a:solidFill>
-          <a:srgbClr val="FFFFFF"/>
+          <a:srgbClr val="E0F0FF"/>
         </a:solidFill>
         <a:effectLst/>
       </p:bgPr>
@@ -10265,7 +10265,7 @@
             <a:avLst/>
           </a:prstGeom>
           <a:solidFill>
-            <a:srgbClr val="2D5016"/>
+            <a:srgbClr val="1B3F6B"/>
           </a:solidFill>
           <a:ln>
             <a:noFill/>
@@ -10319,7 +10319,7 @@
             <a:r>
               <a:rPr sz="3200" b="1" i="0">
                 <a:solidFill>
-                  <a:srgbClr val="FFFFFF"/>
+                  <a:srgbClr val="E0F0FF"/>
                 </a:solidFill>
                 <a:latin typeface="Calibri"/>
               </a:rPr>
@@ -10343,7 +10343,7 @@
             <a:avLst/>
           </a:prstGeom>
           <a:solidFill>
-            <a:srgbClr val="2D5016"/>
+            <a:srgbClr val="1B3F6B"/>
           </a:solidFill>
           <a:ln>
             <a:noFill/>
@@ -10397,7 +10397,7 @@
             <a:r>
               <a:rPr sz="1400" b="1" i="0">
                 <a:solidFill>
-                  <a:srgbClr val="FFFFFF"/>
+                  <a:srgbClr val="E0F0FF"/>
                 </a:solidFill>
                 <a:latin typeface="Calibri"/>
               </a:rPr>
@@ -10421,7 +10421,7 @@
             <a:avLst/>
           </a:prstGeom>
           <a:solidFill>
-            <a:srgbClr val="D6E8C8"/>
+            <a:srgbClr val="C5DCF0"/>
           </a:solidFill>
           <a:ln>
             <a:noFill/>
@@ -10475,7 +10475,7 @@
             <a:r>
               <a:rPr sz="1200" b="0" i="0">
                 <a:solidFill>
-                  <a:srgbClr val="2C2C2C"/>
+                  <a:srgbClr val="1A2A3A"/>
                 </a:solidFill>
                 <a:latin typeface="Calibri"/>
               </a:rPr>
@@ -10510,7 +10510,7 @@
             <a:r>
               <a:rPr sz="1200" b="0" i="0">
                 <a:solidFill>
-                  <a:srgbClr val="2C2C2C"/>
+                  <a:srgbClr val="1A2A3A"/>
                 </a:solidFill>
                 <a:latin typeface="Calibri"/>
               </a:rPr>
@@ -10534,7 +10534,7 @@
             <a:avLst/>
           </a:prstGeom>
           <a:solidFill>
-            <a:srgbClr val="F5F0E8"/>
+            <a:srgbClr val="EBF5FB"/>
           </a:solidFill>
           <a:ln>
             <a:noFill/>
@@ -10588,7 +10588,7 @@
             <a:r>
               <a:rPr sz="1200" b="0" i="0">
                 <a:solidFill>
-                  <a:srgbClr val="2C2C2C"/>
+                  <a:srgbClr val="1A2A3A"/>
                 </a:solidFill>
                 <a:latin typeface="Calibri"/>
               </a:rPr>
@@ -10623,7 +10623,7 @@
             <a:r>
               <a:rPr sz="1200" b="0" i="0">
                 <a:solidFill>
-                  <a:srgbClr val="2C2C2C"/>
+                  <a:srgbClr val="1A2A3A"/>
                 </a:solidFill>
                 <a:latin typeface="Calibri"/>
               </a:rPr>
@@ -10647,7 +10647,7 @@
             <a:avLst/>
           </a:prstGeom>
           <a:solidFill>
-            <a:srgbClr val="D6E8C8"/>
+            <a:srgbClr val="C5DCF0"/>
           </a:solidFill>
           <a:ln>
             <a:noFill/>
@@ -10701,7 +10701,7 @@
             <a:r>
               <a:rPr sz="1200" b="0" i="0">
                 <a:solidFill>
-                  <a:srgbClr val="2C2C2C"/>
+                  <a:srgbClr val="1A2A3A"/>
                 </a:solidFill>
                 <a:latin typeface="Calibri"/>
               </a:rPr>
@@ -10736,7 +10736,7 @@
             <a:r>
               <a:rPr sz="1200" b="0" i="0">
                 <a:solidFill>
-                  <a:srgbClr val="2C2C2C"/>
+                  <a:srgbClr val="1A2A3A"/>
                 </a:solidFill>
                 <a:latin typeface="Calibri"/>
               </a:rPr>
@@ -10760,7 +10760,7 @@
             <a:avLst/>
           </a:prstGeom>
           <a:solidFill>
-            <a:srgbClr val="F5F0E8"/>
+            <a:srgbClr val="EBF5FB"/>
           </a:solidFill>
           <a:ln>
             <a:noFill/>
@@ -10814,7 +10814,7 @@
             <a:r>
               <a:rPr sz="1200" b="0" i="0">
                 <a:solidFill>
-                  <a:srgbClr val="2C2C2C"/>
+                  <a:srgbClr val="1A2A3A"/>
                 </a:solidFill>
                 <a:latin typeface="Calibri"/>
               </a:rPr>
@@ -10849,7 +10849,7 @@
             <a:r>
               <a:rPr sz="1200" b="0" i="0">
                 <a:solidFill>
-                  <a:srgbClr val="2C2C2C"/>
+                  <a:srgbClr val="1A2A3A"/>
                 </a:solidFill>
                 <a:latin typeface="Calibri"/>
               </a:rPr>
@@ -10873,7 +10873,7 @@
             <a:avLst/>
           </a:prstGeom>
           <a:solidFill>
-            <a:srgbClr val="D6E8C8"/>
+            <a:srgbClr val="C5DCF0"/>
           </a:solidFill>
           <a:ln>
             <a:noFill/>
@@ -10927,7 +10927,7 @@
             <a:r>
               <a:rPr sz="1200" b="0" i="0">
                 <a:solidFill>
-                  <a:srgbClr val="2C2C2C"/>
+                  <a:srgbClr val="1A2A3A"/>
                 </a:solidFill>
                 <a:latin typeface="Calibri"/>
               </a:rPr>
@@ -10962,7 +10962,7 @@
             <a:r>
               <a:rPr sz="1200" b="0" i="0">
                 <a:solidFill>
-                  <a:srgbClr val="2C2C2C"/>
+                  <a:srgbClr val="1A2A3A"/>
                 </a:solidFill>
                 <a:latin typeface="Calibri"/>
               </a:rPr>
@@ -10986,7 +10986,7 @@
             <a:avLst/>
           </a:prstGeom>
           <a:solidFill>
-            <a:srgbClr val="F5F0E8"/>
+            <a:srgbClr val="EBF5FB"/>
           </a:solidFill>
           <a:ln>
             <a:noFill/>
@@ -11040,7 +11040,7 @@
             <a:r>
               <a:rPr sz="1200" b="0" i="0">
                 <a:solidFill>
-                  <a:srgbClr val="2C2C2C"/>
+                  <a:srgbClr val="1A2A3A"/>
                 </a:solidFill>
                 <a:latin typeface="Calibri"/>
               </a:rPr>
@@ -11075,7 +11075,7 @@
             <a:r>
               <a:rPr sz="1200" b="0" i="0">
                 <a:solidFill>
-                  <a:srgbClr val="2C2C2C"/>
+                  <a:srgbClr val="1A2A3A"/>
                 </a:solidFill>
                 <a:latin typeface="Calibri"/>
               </a:rPr>
@@ -11099,7 +11099,7 @@
             <a:avLst/>
           </a:prstGeom>
           <a:solidFill>
-            <a:srgbClr val="4A7A28"/>
+            <a:srgbClr val="2E6DA4"/>
           </a:solidFill>
           <a:ln>
             <a:noFill/>
@@ -11153,7 +11153,7 @@
             <a:r>
               <a:rPr sz="1200" b="1" i="0">
                 <a:solidFill>
-                  <a:srgbClr val="FFFFFF"/>
+                  <a:srgbClr val="E0F0FF"/>
                 </a:solidFill>
                 <a:latin typeface="Calibri"/>
               </a:rPr>
@@ -11188,7 +11188,7 @@
             <a:r>
               <a:rPr sz="1200" b="1" i="0">
                 <a:solidFill>
-                  <a:srgbClr val="FFFFFF"/>
+                  <a:srgbClr val="E0F0FF"/>
                 </a:solidFill>
                 <a:latin typeface="Calibri"/>
               </a:rPr>
@@ -11212,7 +11212,7 @@
             <a:avLst/>
           </a:prstGeom>
           <a:solidFill>
-            <a:srgbClr val="2D5016"/>
+            <a:srgbClr val="1B3F6B"/>
           </a:solidFill>
           <a:ln>
             <a:noFill/>
@@ -11266,7 +11266,7 @@
             <a:r>
               <a:rPr sz="1400" b="1" i="0">
                 <a:solidFill>
-                  <a:srgbClr val="FFFFFF"/>
+                  <a:srgbClr val="E0F0FF"/>
                 </a:solidFill>
                 <a:latin typeface="Calibri"/>
               </a:rPr>
@@ -11290,7 +11290,7 @@
             <a:avLst/>
           </a:prstGeom>
           <a:solidFill>
-            <a:srgbClr val="D6E8C8"/>
+            <a:srgbClr val="C5DCF0"/>
           </a:solidFill>
           <a:ln>
             <a:noFill/>
@@ -11344,7 +11344,7 @@
             <a:r>
               <a:rPr sz="1400" b="1" i="0">
                 <a:solidFill>
-                  <a:srgbClr val="2D5016"/>
+                  <a:srgbClr val="1B3F6B"/>
                 </a:solidFill>
                 <a:latin typeface="Calibri"/>
               </a:rPr>
@@ -11379,7 +11379,7 @@
             <a:r>
               <a:rPr sz="1100" b="0" i="0">
                 <a:solidFill>
-                  <a:srgbClr val="2C2C2C"/>
+                  <a:srgbClr val="1A2A3A"/>
                 </a:solidFill>
                 <a:latin typeface="Calibri"/>
               </a:rPr>
@@ -11403,7 +11403,7 @@
             <a:avLst/>
           </a:prstGeom>
           <a:solidFill>
-            <a:srgbClr val="F5F0E8"/>
+            <a:srgbClr val="EBF5FB"/>
           </a:solidFill>
           <a:ln>
             <a:noFill/>
@@ -11457,7 +11457,7 @@
             <a:r>
               <a:rPr sz="1400" b="1" i="0">
                 <a:solidFill>
-                  <a:srgbClr val="2D5016"/>
+                  <a:srgbClr val="1B3F6B"/>
                 </a:solidFill>
                 <a:latin typeface="Calibri"/>
               </a:rPr>
@@ -11492,7 +11492,7 @@
             <a:r>
               <a:rPr sz="1100" b="0" i="0">
                 <a:solidFill>
-                  <a:srgbClr val="2C2C2C"/>
+                  <a:srgbClr val="1A2A3A"/>
                 </a:solidFill>
                 <a:latin typeface="Calibri"/>
               </a:rPr>
@@ -11516,7 +11516,7 @@
             <a:avLst/>
           </a:prstGeom>
           <a:solidFill>
-            <a:srgbClr val="D6E8C8"/>
+            <a:srgbClr val="C5DCF0"/>
           </a:solidFill>
           <a:ln>
             <a:noFill/>
@@ -11570,7 +11570,7 @@
             <a:r>
               <a:rPr sz="1400" b="1" i="0">
                 <a:solidFill>
-                  <a:srgbClr val="2D5016"/>
+                  <a:srgbClr val="1B3F6B"/>
                 </a:solidFill>
                 <a:latin typeface="Calibri"/>
               </a:rPr>
@@ -11605,7 +11605,7 @@
             <a:r>
               <a:rPr sz="1100" b="0" i="0">
                 <a:solidFill>
-                  <a:srgbClr val="2C2C2C"/>
+                  <a:srgbClr val="1A2A3A"/>
                 </a:solidFill>
                 <a:latin typeface="Calibri"/>
               </a:rPr>
@@ -11629,7 +11629,7 @@
             <a:avLst/>
           </a:prstGeom>
           <a:solidFill>
-            <a:srgbClr val="F5F0E8"/>
+            <a:srgbClr val="EBF5FB"/>
           </a:solidFill>
           <a:ln>
             <a:noFill/>
@@ -11683,7 +11683,7 @@
             <a:r>
               <a:rPr sz="1400" b="1" i="0">
                 <a:solidFill>
-                  <a:srgbClr val="2D5016"/>
+                  <a:srgbClr val="1B3F6B"/>
                 </a:solidFill>
                 <a:latin typeface="Calibri"/>
               </a:rPr>
@@ -11718,7 +11718,7 @@
             <a:r>
               <a:rPr sz="1100" b="0" i="0">
                 <a:solidFill>
-                  <a:srgbClr val="2C2C2C"/>
+                  <a:srgbClr val="1A2A3A"/>
                 </a:solidFill>
                 <a:latin typeface="Calibri"/>
               </a:rPr>
@@ -11742,7 +11742,7 @@
             <a:avLst/>
           </a:prstGeom>
           <a:solidFill>
-            <a:srgbClr val="D6E8C8"/>
+            <a:srgbClr val="C5DCF0"/>
           </a:solidFill>
           <a:ln>
             <a:noFill/>
@@ -11796,7 +11796,7 @@
             <a:r>
               <a:rPr sz="1400" b="1" i="0">
                 <a:solidFill>
-                  <a:srgbClr val="2D5016"/>
+                  <a:srgbClr val="1B3F6B"/>
                 </a:solidFill>
                 <a:latin typeface="Calibri"/>
               </a:rPr>
@@ -11831,7 +11831,7 @@
             <a:r>
               <a:rPr sz="1100" b="0" i="0">
                 <a:solidFill>
-                  <a:srgbClr val="2C2C2C"/>
+                  <a:srgbClr val="1A2A3A"/>
                 </a:solidFill>
                 <a:latin typeface="Calibri"/>
               </a:rPr>
@@ -11855,7 +11855,7 @@
             <a:avLst/>
           </a:prstGeom>
           <a:solidFill>
-            <a:srgbClr val="F5F0E8"/>
+            <a:srgbClr val="EBF5FB"/>
           </a:solidFill>
           <a:ln>
             <a:noFill/>
@@ -11909,7 +11909,7 @@
             <a:r>
               <a:rPr sz="1400" b="1" i="0">
                 <a:solidFill>
-                  <a:srgbClr val="2D5016"/>
+                  <a:srgbClr val="1B3F6B"/>
                 </a:solidFill>
                 <a:latin typeface="Calibri"/>
               </a:rPr>
@@ -11944,7 +11944,7 @@
             <a:r>
               <a:rPr sz="1100" b="0" i="0">
                 <a:solidFill>
-                  <a:srgbClr val="2C2C2C"/>
+                  <a:srgbClr val="1A2A3A"/>
                 </a:solidFill>
                 <a:latin typeface="Calibri"/>
               </a:rPr>
@@ -11968,7 +11968,7 @@
             <a:avLst/>
           </a:prstGeom>
           <a:solidFill>
-            <a:srgbClr val="8FAF7E"/>
+            <a:srgbClr val="5B9BD5"/>
           </a:solidFill>
           <a:ln>
             <a:noFill/>
@@ -12022,7 +12022,7 @@
             <a:r>
               <a:rPr sz="1000" b="0" i="0">
                 <a:solidFill>
-                  <a:srgbClr val="2C2C2C"/>
+                  <a:srgbClr val="1A2A3A"/>
                 </a:solidFill>
                 <a:latin typeface="Calibri"/>
               </a:rPr>

</xml_diff>